<commit_message>
feat: complete all EDA visualizations, findings cells, and reports
</commit_message>
<xml_diff>
--- a/reports/Presentation.pptx
+++ b/reports/Presentation.pptx
@@ -17,6 +17,9 @@
     <p:sldId id="265" r:id="rId16"/>
     <p:sldId id="266" r:id="rId17"/>
     <p:sldId id="267" r:id="rId18"/>
+    <p:sldId id="268" r:id="rId19"/>
+    <p:sldId id="269" r:id="rId20"/>
+    <p:sldId id="270" r:id="rId21"/>
   </p:sldIdLst>
   <p:sldSz cx="9144000" cy="6858000" type="screen4x3"/>
   <p:notesSz cx="6858000" cy="9144000"/>
@@ -3248,7 +3251,7 @@
               </a:defRPr>
             </a:pPr>
             <a:r>
-              <a:t>Quantitative Fund Performance</a:t>
+              <a:t>EDA: Investor Segmentation &amp; Demographics</a:t>
             </a:r>
           </a:p>
         </p:txBody>
@@ -3261,8 +3264,8 @@
         </p:nvSpPr>
         <p:spPr>
           <a:xfrm>
-            <a:off x="457200" y="1188720"/>
-            <a:ext cx="7772400" cy="4572000"/>
+            <a:off x="457200" y="1097280"/>
+            <a:ext cx="8229600" cy="2286000"/>
           </a:xfrm>
           <a:prstGeom prst="rect">
             <a:avLst/>
@@ -3279,15 +3282,15 @@
               <a:spcAft>
                 <a:spcPts val="800"/>
               </a:spcAft>
-              <a:defRPr sz="1600">
-                <a:solidFill>
-                  <a:srgbClr val="0F172A"/>
-                </a:solidFill>
-                <a:latin typeface="Arial"/>
-              </a:defRPr>
-            </a:pPr>
-            <a:r>
-              <a:t>Key mathematical returns and risk indicators calculated:</a:t>
+              <a:defRPr sz="1500">
+                <a:solidFill>
+                  <a:srgbClr val="0F172A"/>
+                </a:solidFill>
+                <a:latin typeface="Arial"/>
+              </a:defRPr>
+            </a:pPr>
+            <a:r>
+              <a:t>Age splits: 26-35 bracket dominates (36% count).</a:t>
             </a:r>
           </a:p>
           <a:p>
@@ -3295,15 +3298,15 @@
               <a:spcAft>
                 <a:spcPts val="800"/>
               </a:spcAft>
-              <a:defRPr sz="1600">
-                <a:solidFill>
-                  <a:srgbClr val="0F172A"/>
-                </a:solidFill>
-                <a:latin typeface="Arial"/>
-              </a:defRPr>
-            </a:pPr>
-            <a:r>
-              <a:t>CAGR Returns: Calculated for 1-year, 3-year, and 5-year periods.</a:t>
+              <a:defRPr sz="1500">
+                <a:solidFill>
+                  <a:srgbClr val="0F172A"/>
+                </a:solidFill>
+                <a:latin typeface="Arial"/>
+              </a:defRPr>
+            </a:pPr>
+            <a:r>
+              <a:t>Ticket sizes: 46-55 group displays the highest average SIP amount.</a:t>
             </a:r>
           </a:p>
           <a:p>
@@ -3311,83 +3314,91 @@
               <a:spcAft>
                 <a:spcPts val="800"/>
               </a:spcAft>
-              <a:defRPr sz="1600">
-                <a:solidFill>
-                  <a:srgbClr val="0F172A"/>
-                </a:solidFill>
-                <a:latin typeface="Arial"/>
-              </a:defRPr>
-            </a:pPr>
-            <a:r>
-              <a:t>Sharpe Ratio: Measures risk-adjusted excess returns over 6.5% Rf rate.</a:t>
-            </a:r>
-          </a:p>
-          <a:p>
-            <a:pPr>
-              <a:spcAft>
-                <a:spcPts val="800"/>
-              </a:spcAft>
-              <a:defRPr sz="1600">
-                <a:solidFill>
-                  <a:srgbClr val="0F172A"/>
-                </a:solidFill>
-                <a:latin typeface="Arial"/>
-              </a:defRPr>
-            </a:pPr>
-            <a:r>
-              <a:t>Sortino Ratio: Penalizes only downside volatility (negative returns).</a:t>
-            </a:r>
-          </a:p>
-          <a:p>
-            <a:pPr>
-              <a:spcAft>
-                <a:spcPts val="800"/>
-              </a:spcAft>
-              <a:defRPr sz="1600">
-                <a:solidFill>
-                  <a:srgbClr val="0F172A"/>
-                </a:solidFill>
-                <a:latin typeface="Arial"/>
-              </a:defRPr>
-            </a:pPr>
-            <a:r>
-              <a:t>Beta &amp; Alpha: Aligned index prices to regress fund performance.</a:t>
-            </a:r>
-          </a:p>
-          <a:p>
-            <a:pPr>
-              <a:spcAft>
-                <a:spcPts val="800"/>
-              </a:spcAft>
-              <a:defRPr sz="1600">
-                <a:solidFill>
-                  <a:srgbClr val="0F172A"/>
-                </a:solidFill>
-                <a:latin typeface="Arial"/>
-              </a:defRPr>
-            </a:pPr>
-            <a:r>
-              <a:t>Maximum Drawdowns: Traced worst-case peak-to-trough drop rates.</a:t>
-            </a:r>
-          </a:p>
-          <a:p>
-            <a:pPr>
-              <a:spcAft>
-                <a:spcPts val="800"/>
-              </a:spcAft>
-              <a:defRPr sz="1600">
-                <a:solidFill>
-                  <a:srgbClr val="0F172A"/>
-                </a:solidFill>
-                <a:latin typeface="Arial"/>
-              </a:defRPr>
-            </a:pPr>
-            <a:r>
-              <a:t>Scorecard: Weighted ranks to construct a composite score out of 100.</a:t>
-            </a:r>
-          </a:p>
-        </p:txBody>
-      </p:sp>
+              <a:defRPr sz="1500">
+                <a:solidFill>
+                  <a:srgbClr val="0F172A"/>
+                </a:solidFill>
+                <a:latin typeface="Arial"/>
+              </a:defRPr>
+            </a:pPr>
+            <a:r>
+              <a:t>Gender split: Men contribute ~66% vs. Women ~34% of total investments.</a:t>
+            </a:r>
+          </a:p>
+        </p:txBody>
+      </p:sp>
+      <p:pic>
+        <p:nvPicPr>
+          <p:cNvPr id="4" name="Picture 3" descr="investor_age_pie.png"/>
+          <p:cNvPicPr>
+            <a:picLocks noChangeAspect="1"/>
+          </p:cNvPicPr>
+          <p:nvPr/>
+        </p:nvPicPr>
+        <p:blipFill>
+          <a:blip r:embed="rId2"/>
+          <a:stretch>
+            <a:fillRect/>
+          </a:stretch>
+        </p:blipFill>
+        <p:spPr>
+          <a:xfrm>
+            <a:off x="457200" y="3657600"/>
+            <a:ext cx="2560320" cy="2286000"/>
+          </a:xfrm>
+          <a:prstGeom prst="rect">
+            <a:avLst/>
+          </a:prstGeom>
+        </p:spPr>
+      </p:pic>
+      <p:pic>
+        <p:nvPicPr>
+          <p:cNvPr id="5" name="Picture 4" descr="investor_sip_boxplot.png"/>
+          <p:cNvPicPr>
+            <a:picLocks noChangeAspect="1"/>
+          </p:cNvPicPr>
+          <p:nvPr/>
+        </p:nvPicPr>
+        <p:blipFill>
+          <a:blip r:embed="rId3"/>
+          <a:stretch>
+            <a:fillRect/>
+          </a:stretch>
+        </p:blipFill>
+        <p:spPr>
+          <a:xfrm>
+            <a:off x="3291840" y="3657600"/>
+            <a:ext cx="2560320" cy="2286000"/>
+          </a:xfrm>
+          <a:prstGeom prst="rect">
+            <a:avLst/>
+          </a:prstGeom>
+        </p:spPr>
+      </p:pic>
+      <p:pic>
+        <p:nvPicPr>
+          <p:cNvPr id="6" name="Picture 5" descr="investor_gender_split.png"/>
+          <p:cNvPicPr>
+            <a:picLocks noChangeAspect="1"/>
+          </p:cNvPicPr>
+          <p:nvPr/>
+        </p:nvPicPr>
+        <p:blipFill>
+          <a:blip r:embed="rId4"/>
+          <a:stretch>
+            <a:fillRect/>
+          </a:stretch>
+        </p:blipFill>
+        <p:spPr>
+          <a:xfrm>
+            <a:off x="6126480" y="3657600"/>
+            <a:ext cx="2560320" cy="2286000"/>
+          </a:xfrm>
+          <a:prstGeom prst="rect">
+            <a:avLst/>
+          </a:prstGeom>
+        </p:spPr>
+      </p:pic>
     </p:spTree>
   </p:cSld>
   <p:clrMapOvr>
@@ -3437,7 +3448,7 @@
               </a:defRPr>
             </a:pPr>
             <a:r>
-              <a:t>Advanced Analytics &amp; Risk Modules</a:t>
+              <a:t>EDA: Geographic &amp; City Tier Analysis</a:t>
             </a:r>
           </a:p>
         </p:txBody>
@@ -3451,7 +3462,7 @@
         <p:spPr>
           <a:xfrm>
             <a:off x="457200" y="1188720"/>
-            <a:ext cx="7772400" cy="4572000"/>
+            <a:ext cx="4114800" cy="4572000"/>
           </a:xfrm>
           <a:prstGeom prst="rect">
             <a:avLst/>
@@ -3476,7 +3487,7 @@
               </a:defRPr>
             </a:pPr>
             <a:r>
-              <a:t>Value at Risk (VaR 95%) &amp; CVaR</a:t>
+              <a:t>State SIP Inflows:</a:t>
             </a:r>
           </a:p>
           <a:p>
@@ -3489,7 +3500,20 @@
               </a:defRPr>
             </a:pPr>
             <a:r>
-              <a:t>Daily historical worst-case expected loss metrics for each fund.</a:t>
+              <a:t>Madhya Pradesh, Punjab and Telangana lead active SIP amounts.</a:t>
+            </a:r>
+          </a:p>
+          <a:p>
+            <a:pPr lvl="1">
+              <a:defRPr sz="1600">
+                <a:solidFill>
+                  <a:srgbClr val="0F172A"/>
+                </a:solidFill>
+                <a:latin typeface="Arial"/>
+              </a:defRPr>
+            </a:pPr>
+            <a:r>
+              <a:t>Reflects growing wealth in tier-2/3 state capitals.</a:t>
             </a:r>
           </a:p>
           <a:p>
@@ -3505,7 +3529,7 @@
               </a:defRPr>
             </a:pPr>
             <a:r>
-              <a:t>HHI Sector Concentration Index</a:t>
+              <a:t>T30 vs. B30 City Tier splits:</a:t>
             </a:r>
           </a:p>
           <a:p>
@@ -3518,23 +3542,7 @@
               </a:defRPr>
             </a:pPr>
             <a:r>
-              <a:t>Quantifies portfolio concentration risk. Financial services average &gt; 25%.</a:t>
-            </a:r>
-          </a:p>
-          <a:p>
-            <a:pPr>
-              <a:spcAft>
-                <a:spcPts val="800"/>
-              </a:spcAft>
-              <a:defRPr sz="1600">
-                <a:solidFill>
-                  <a:srgbClr val="0F172A"/>
-                </a:solidFill>
-                <a:latin typeface="Arial"/>
-              </a:defRPr>
-            </a:pPr>
-            <a:r>
-              <a:t>SIP Churn Prediction Model</a:t>
+              <a:t>Top 30 (T30) cities still hold the lion's share of investments (66%).</a:t>
             </a:r>
           </a:p>
           <a:p>
@@ -3547,40 +3555,59 @@
               </a:defRPr>
             </a:pPr>
             <a:r>
-              <a:t>Flags investors with transaction gaps &gt; 35 days as 'at-risk'.</a:t>
-            </a:r>
-          </a:p>
-          <a:p>
-            <a:pPr>
-              <a:spcAft>
-                <a:spcPts val="800"/>
-              </a:spcAft>
-              <a:defRPr sz="1600">
-                <a:solidFill>
-                  <a:srgbClr val="0F172A"/>
-                </a:solidFill>
-                <a:latin typeface="Arial"/>
-              </a:defRPr>
-            </a:pPr>
-            <a:r>
-              <a:t>Risk Recommender Engine (recommender.py)</a:t>
-            </a:r>
-          </a:p>
-          <a:p>
-            <a:pPr lvl="1">
-              <a:defRPr sz="1600">
-                <a:solidFill>
-                  <a:srgbClr val="0F172A"/>
-                </a:solidFill>
-                <a:latin typeface="Arial"/>
-              </a:defRPr>
-            </a:pPr>
-            <a:r>
-              <a:t>Programmatic lookup matching risk appetites to top Sharpe ratio funds.</a:t>
-            </a:r>
-          </a:p>
-        </p:txBody>
-      </p:sp>
+              <a:t>Beyond-30 (B30) cities represent a massive growth opportunity (34%).</a:t>
+            </a:r>
+          </a:p>
+        </p:txBody>
+      </p:sp>
+      <p:pic>
+        <p:nvPicPr>
+          <p:cNvPr id="4" name="Picture 3" descr="geo_state_sip.png"/>
+          <p:cNvPicPr>
+            <a:picLocks noChangeAspect="1"/>
+          </p:cNvPicPr>
+          <p:nvPr/>
+        </p:nvPicPr>
+        <p:blipFill>
+          <a:blip r:embed="rId2"/>
+          <a:stretch>
+            <a:fillRect/>
+          </a:stretch>
+        </p:blipFill>
+        <p:spPr>
+          <a:xfrm>
+            <a:off x="4754880" y="1188720"/>
+            <a:ext cx="3931920" cy="2377440"/>
+          </a:xfrm>
+          <a:prstGeom prst="rect">
+            <a:avLst/>
+          </a:prstGeom>
+        </p:spPr>
+      </p:pic>
+      <p:pic>
+        <p:nvPicPr>
+          <p:cNvPr id="5" name="Picture 4" descr="geo_tier_pie.png"/>
+          <p:cNvPicPr>
+            <a:picLocks noChangeAspect="1"/>
+          </p:cNvPicPr>
+          <p:nvPr/>
+        </p:nvPicPr>
+        <p:blipFill>
+          <a:blip r:embed="rId3"/>
+          <a:stretch>
+            <a:fillRect/>
+          </a:stretch>
+        </p:blipFill>
+        <p:spPr>
+          <a:xfrm>
+            <a:off x="4754880" y="3840480"/>
+            <a:ext cx="3931920" cy="2377440"/>
+          </a:xfrm>
+          <a:prstGeom prst="rect">
+            <a:avLst/>
+          </a:prstGeom>
+        </p:spPr>
+      </p:pic>
     </p:spTree>
   </p:cSld>
   <p:clrMapOvr>
@@ -3630,6 +3657,597 @@
               </a:defRPr>
             </a:pPr>
             <a:r>
+              <a:t>EDA: Folio Progression &amp; Sector Weights</a:t>
+            </a:r>
+          </a:p>
+        </p:txBody>
+      </p:sp>
+      <p:sp>
+        <p:nvSpPr>
+          <p:cNvPr id="3" name="TextBox 2"/>
+          <p:cNvSpPr txBox="1"/>
+          <p:nvPr/>
+        </p:nvSpPr>
+        <p:spPr>
+          <a:xfrm>
+            <a:off x="457200" y="1188720"/>
+            <a:ext cx="4114800" cy="4572000"/>
+          </a:xfrm>
+          <a:prstGeom prst="rect">
+            <a:avLst/>
+          </a:prstGeom>
+          <a:noFill/>
+        </p:spPr>
+        <p:txBody>
+          <a:bodyPr wrap="square">
+            <a:spAutoFit/>
+          </a:bodyPr>
+          <a:lstStyle/>
+          <a:p>
+            <a:pPr>
+              <a:spcAft>
+                <a:spcPts val="800"/>
+              </a:spcAft>
+              <a:defRPr sz="1600">
+                <a:solidFill>
+                  <a:srgbClr val="0F172A"/>
+                </a:solidFill>
+                <a:latin typeface="Arial"/>
+              </a:defRPr>
+            </a:pPr>
+            <a:r>
+              <a:t>Folio Expansion:</a:t>
+            </a:r>
+          </a:p>
+          <a:p>
+            <a:pPr lvl="1">
+              <a:defRPr sz="1600">
+                <a:solidFill>
+                  <a:srgbClr val="0F172A"/>
+                </a:solidFill>
+                <a:latin typeface="Arial"/>
+              </a:defRPr>
+            </a:pPr>
+            <a:r>
+              <a:t>Doubled from 13.26 Cr (Jan 2022) to 26.12 Cr (Dec 2025).</a:t>
+            </a:r>
+          </a:p>
+          <a:p>
+            <a:pPr lvl="1">
+              <a:defRPr sz="1600">
+                <a:solidFill>
+                  <a:srgbClr val="0F172A"/>
+                </a:solidFill>
+                <a:latin typeface="Arial"/>
+              </a:defRPr>
+            </a:pPr>
+            <a:r>
+              <a:t>Crossed the 20 Crore milestone in July 2024.</a:t>
+            </a:r>
+          </a:p>
+          <a:p>
+            <a:pPr>
+              <a:spcAft>
+                <a:spcPts val="800"/>
+              </a:spcAft>
+              <a:defRPr sz="1600">
+                <a:solidFill>
+                  <a:srgbClr val="0F172A"/>
+                </a:solidFill>
+                <a:latin typeface="Arial"/>
+              </a:defRPr>
+            </a:pPr>
+            <a:r>
+              <a:t>Sector Weights Allocation (Equity Donut):</a:t>
+            </a:r>
+          </a:p>
+          <a:p>
+            <a:pPr lvl="1">
+              <a:defRPr sz="1600">
+                <a:solidFill>
+                  <a:srgbClr val="0F172A"/>
+                </a:solidFill>
+                <a:latin typeface="Arial"/>
+              </a:defRPr>
+            </a:pPr>
+            <a:r>
+              <a:t>High concentration in Financial Services (&gt; 25%).</a:t>
+            </a:r>
+          </a:p>
+          <a:p>
+            <a:pPr lvl="1">
+              <a:defRPr sz="1600">
+                <a:solidFill>
+                  <a:srgbClr val="0F172A"/>
+                </a:solidFill>
+                <a:latin typeface="Arial"/>
+              </a:defRPr>
+            </a:pPr>
+            <a:r>
+              <a:t>Reflects major benchmarks (Nifty 50/Nifty 100) sector dominance.</a:t>
+            </a:r>
+          </a:p>
+        </p:txBody>
+      </p:sp>
+      <p:pic>
+        <p:nvPicPr>
+          <p:cNvPr id="4" name="Picture 3" descr="folio_growth_milestones.png"/>
+          <p:cNvPicPr>
+            <a:picLocks noChangeAspect="1"/>
+          </p:cNvPicPr>
+          <p:nvPr/>
+        </p:nvPicPr>
+        <p:blipFill>
+          <a:blip r:embed="rId2"/>
+          <a:stretch>
+            <a:fillRect/>
+          </a:stretch>
+        </p:blipFill>
+        <p:spPr>
+          <a:xfrm>
+            <a:off x="4754880" y="1188720"/>
+            <a:ext cx="3931920" cy="2377440"/>
+          </a:xfrm>
+          <a:prstGeom prst="rect">
+            <a:avLst/>
+          </a:prstGeom>
+        </p:spPr>
+      </p:pic>
+      <p:pic>
+        <p:nvPicPr>
+          <p:cNvPr id="5" name="Picture 4" descr="sector_allocation_donut.png"/>
+          <p:cNvPicPr>
+            <a:picLocks noChangeAspect="1"/>
+          </p:cNvPicPr>
+          <p:nvPr/>
+        </p:nvPicPr>
+        <p:blipFill>
+          <a:blip r:embed="rId3"/>
+          <a:stretch>
+            <a:fillRect/>
+          </a:stretch>
+        </p:blipFill>
+        <p:spPr>
+          <a:xfrm>
+            <a:off x="4754880" y="3840480"/>
+            <a:ext cx="3931920" cy="2377440"/>
+          </a:xfrm>
+          <a:prstGeom prst="rect">
+            <a:avLst/>
+          </a:prstGeom>
+        </p:spPr>
+      </p:pic>
+    </p:spTree>
+  </p:cSld>
+  <p:clrMapOvr>
+    <a:masterClrMapping/>
+  </p:clrMapOvr>
+</p:sld>
+</file>
+
+<file path=ppt/slides/slide13.xml><?xml version="1.0" encoding="utf-8"?>
+<p:sld xmlns:a="http://schemas.openxmlformats.org/drawingml/2006/main" xmlns:p="http://schemas.openxmlformats.org/presentationml/2006/main" xmlns:r="http://schemas.openxmlformats.org/officeDocument/2006/relationships">
+  <p:cSld>
+    <p:spTree>
+      <p:nvGrpSpPr>
+        <p:cNvPr id="1" name=""/>
+        <p:cNvGrpSpPr/>
+        <p:nvPr/>
+      </p:nvGrpSpPr>
+      <p:grpSpPr/>
+      <p:sp>
+        <p:nvSpPr>
+          <p:cNvPr id="2" name="TextBox 1"/>
+          <p:cNvSpPr txBox="1"/>
+          <p:nvPr/>
+        </p:nvSpPr>
+        <p:spPr>
+          <a:xfrm>
+            <a:off x="457200" y="365760"/>
+            <a:ext cx="8229600" cy="731520"/>
+          </a:xfrm>
+          <a:prstGeom prst="rect">
+            <a:avLst/>
+          </a:prstGeom>
+          <a:noFill/>
+        </p:spPr>
+        <p:txBody>
+          <a:bodyPr wrap="square">
+            <a:spAutoFit/>
+          </a:bodyPr>
+          <a:lstStyle/>
+          <a:p>
+            <a:pPr>
+              <a:defRPr sz="3600" b="1">
+                <a:solidFill>
+                  <a:srgbClr val="1E3A8A"/>
+                </a:solidFill>
+                <a:latin typeface="Arial"/>
+              </a:defRPr>
+            </a:pPr>
+            <a:r>
+              <a:t>Quantitative Fund Performance</a:t>
+            </a:r>
+          </a:p>
+        </p:txBody>
+      </p:sp>
+      <p:sp>
+        <p:nvSpPr>
+          <p:cNvPr id="3" name="TextBox 2"/>
+          <p:cNvSpPr txBox="1"/>
+          <p:nvPr/>
+        </p:nvSpPr>
+        <p:spPr>
+          <a:xfrm>
+            <a:off x="457200" y="1188720"/>
+            <a:ext cx="7772400" cy="4572000"/>
+          </a:xfrm>
+          <a:prstGeom prst="rect">
+            <a:avLst/>
+          </a:prstGeom>
+          <a:noFill/>
+        </p:spPr>
+        <p:txBody>
+          <a:bodyPr wrap="square">
+            <a:spAutoFit/>
+          </a:bodyPr>
+          <a:lstStyle/>
+          <a:p>
+            <a:pPr>
+              <a:spcAft>
+                <a:spcPts val="800"/>
+              </a:spcAft>
+              <a:defRPr sz="1600">
+                <a:solidFill>
+                  <a:srgbClr val="0F172A"/>
+                </a:solidFill>
+                <a:latin typeface="Arial"/>
+              </a:defRPr>
+            </a:pPr>
+            <a:r>
+              <a:t>Key mathematical returns and risk indicators calculated:</a:t>
+            </a:r>
+          </a:p>
+          <a:p>
+            <a:pPr>
+              <a:spcAft>
+                <a:spcPts val="800"/>
+              </a:spcAft>
+              <a:defRPr sz="1600">
+                <a:solidFill>
+                  <a:srgbClr val="0F172A"/>
+                </a:solidFill>
+                <a:latin typeface="Arial"/>
+              </a:defRPr>
+            </a:pPr>
+            <a:r>
+              <a:t>CAGR Returns: Calculated for 1-year, 3-year, and 5-year periods.</a:t>
+            </a:r>
+          </a:p>
+          <a:p>
+            <a:pPr>
+              <a:spcAft>
+                <a:spcPts val="800"/>
+              </a:spcAft>
+              <a:defRPr sz="1600">
+                <a:solidFill>
+                  <a:srgbClr val="0F172A"/>
+                </a:solidFill>
+                <a:latin typeface="Arial"/>
+              </a:defRPr>
+            </a:pPr>
+            <a:r>
+              <a:t>Sharpe Ratio: Measures risk-adjusted excess returns over 6.5% Rf rate.</a:t>
+            </a:r>
+          </a:p>
+          <a:p>
+            <a:pPr>
+              <a:spcAft>
+                <a:spcPts val="800"/>
+              </a:spcAft>
+              <a:defRPr sz="1600">
+                <a:solidFill>
+                  <a:srgbClr val="0F172A"/>
+                </a:solidFill>
+                <a:latin typeface="Arial"/>
+              </a:defRPr>
+            </a:pPr>
+            <a:r>
+              <a:t>Sortino Ratio: Penalizes only downside volatility (negative returns).</a:t>
+            </a:r>
+          </a:p>
+          <a:p>
+            <a:pPr>
+              <a:spcAft>
+                <a:spcPts val="800"/>
+              </a:spcAft>
+              <a:defRPr sz="1600">
+                <a:solidFill>
+                  <a:srgbClr val="0F172A"/>
+                </a:solidFill>
+                <a:latin typeface="Arial"/>
+              </a:defRPr>
+            </a:pPr>
+            <a:r>
+              <a:t>Beta &amp; Alpha: Aligned index prices to regress fund performance.</a:t>
+            </a:r>
+          </a:p>
+          <a:p>
+            <a:pPr>
+              <a:spcAft>
+                <a:spcPts val="800"/>
+              </a:spcAft>
+              <a:defRPr sz="1600">
+                <a:solidFill>
+                  <a:srgbClr val="0F172A"/>
+                </a:solidFill>
+                <a:latin typeface="Arial"/>
+              </a:defRPr>
+            </a:pPr>
+            <a:r>
+              <a:t>Maximum Drawdowns: Traced worst-case peak-to-trough drop rates.</a:t>
+            </a:r>
+          </a:p>
+          <a:p>
+            <a:pPr>
+              <a:spcAft>
+                <a:spcPts val="800"/>
+              </a:spcAft>
+              <a:defRPr sz="1600">
+                <a:solidFill>
+                  <a:srgbClr val="0F172A"/>
+                </a:solidFill>
+                <a:latin typeface="Arial"/>
+              </a:defRPr>
+            </a:pPr>
+            <a:r>
+              <a:t>Scorecard: Weighted ranks to construct a composite score out of 100.</a:t>
+            </a:r>
+          </a:p>
+        </p:txBody>
+      </p:sp>
+    </p:spTree>
+  </p:cSld>
+  <p:clrMapOvr>
+    <a:masterClrMapping/>
+  </p:clrMapOvr>
+</p:sld>
+</file>
+
+<file path=ppt/slides/slide14.xml><?xml version="1.0" encoding="utf-8"?>
+<p:sld xmlns:a="http://schemas.openxmlformats.org/drawingml/2006/main" xmlns:p="http://schemas.openxmlformats.org/presentationml/2006/main" xmlns:r="http://schemas.openxmlformats.org/officeDocument/2006/relationships">
+  <p:cSld>
+    <p:spTree>
+      <p:nvGrpSpPr>
+        <p:cNvPr id="1" name=""/>
+        <p:cNvGrpSpPr/>
+        <p:nvPr/>
+      </p:nvGrpSpPr>
+      <p:grpSpPr/>
+      <p:sp>
+        <p:nvSpPr>
+          <p:cNvPr id="2" name="TextBox 1"/>
+          <p:cNvSpPr txBox="1"/>
+          <p:nvPr/>
+        </p:nvSpPr>
+        <p:spPr>
+          <a:xfrm>
+            <a:off x="457200" y="365760"/>
+            <a:ext cx="8229600" cy="731520"/>
+          </a:xfrm>
+          <a:prstGeom prst="rect">
+            <a:avLst/>
+          </a:prstGeom>
+          <a:noFill/>
+        </p:spPr>
+        <p:txBody>
+          <a:bodyPr wrap="square">
+            <a:spAutoFit/>
+          </a:bodyPr>
+          <a:lstStyle/>
+          <a:p>
+            <a:pPr>
+              <a:defRPr sz="3600" b="1">
+                <a:solidFill>
+                  <a:srgbClr val="1E3A8A"/>
+                </a:solidFill>
+                <a:latin typeface="Arial"/>
+              </a:defRPr>
+            </a:pPr>
+            <a:r>
+              <a:t>Advanced Analytics &amp; Risk Modules</a:t>
+            </a:r>
+          </a:p>
+        </p:txBody>
+      </p:sp>
+      <p:sp>
+        <p:nvSpPr>
+          <p:cNvPr id="3" name="TextBox 2"/>
+          <p:cNvSpPr txBox="1"/>
+          <p:nvPr/>
+        </p:nvSpPr>
+        <p:spPr>
+          <a:xfrm>
+            <a:off x="457200" y="1188720"/>
+            <a:ext cx="7772400" cy="4572000"/>
+          </a:xfrm>
+          <a:prstGeom prst="rect">
+            <a:avLst/>
+          </a:prstGeom>
+          <a:noFill/>
+        </p:spPr>
+        <p:txBody>
+          <a:bodyPr wrap="square">
+            <a:spAutoFit/>
+          </a:bodyPr>
+          <a:lstStyle/>
+          <a:p>
+            <a:pPr>
+              <a:spcAft>
+                <a:spcPts val="800"/>
+              </a:spcAft>
+              <a:defRPr sz="1600">
+                <a:solidFill>
+                  <a:srgbClr val="0F172A"/>
+                </a:solidFill>
+                <a:latin typeface="Arial"/>
+              </a:defRPr>
+            </a:pPr>
+            <a:r>
+              <a:t>Value at Risk (VaR 95%) &amp; CVaR</a:t>
+            </a:r>
+          </a:p>
+          <a:p>
+            <a:pPr lvl="1">
+              <a:defRPr sz="1600">
+                <a:solidFill>
+                  <a:srgbClr val="0F172A"/>
+                </a:solidFill>
+                <a:latin typeface="Arial"/>
+              </a:defRPr>
+            </a:pPr>
+            <a:r>
+              <a:t>Daily historical worst-case expected loss metrics for each fund.</a:t>
+            </a:r>
+          </a:p>
+          <a:p>
+            <a:pPr>
+              <a:spcAft>
+                <a:spcPts val="800"/>
+              </a:spcAft>
+              <a:defRPr sz="1600">
+                <a:solidFill>
+                  <a:srgbClr val="0F172A"/>
+                </a:solidFill>
+                <a:latin typeface="Arial"/>
+              </a:defRPr>
+            </a:pPr>
+            <a:r>
+              <a:t>HHI Sector Concentration Index</a:t>
+            </a:r>
+          </a:p>
+          <a:p>
+            <a:pPr lvl="1">
+              <a:defRPr sz="1600">
+                <a:solidFill>
+                  <a:srgbClr val="0F172A"/>
+                </a:solidFill>
+                <a:latin typeface="Arial"/>
+              </a:defRPr>
+            </a:pPr>
+            <a:r>
+              <a:t>Quantifies portfolio concentration risk. Financial services average &gt; 25%.</a:t>
+            </a:r>
+          </a:p>
+          <a:p>
+            <a:pPr>
+              <a:spcAft>
+                <a:spcPts val="800"/>
+              </a:spcAft>
+              <a:defRPr sz="1600">
+                <a:solidFill>
+                  <a:srgbClr val="0F172A"/>
+                </a:solidFill>
+                <a:latin typeface="Arial"/>
+              </a:defRPr>
+            </a:pPr>
+            <a:r>
+              <a:t>SIP Churn Prediction Model</a:t>
+            </a:r>
+          </a:p>
+          <a:p>
+            <a:pPr lvl="1">
+              <a:defRPr sz="1600">
+                <a:solidFill>
+                  <a:srgbClr val="0F172A"/>
+                </a:solidFill>
+                <a:latin typeface="Arial"/>
+              </a:defRPr>
+            </a:pPr>
+            <a:r>
+              <a:t>Flags investors with transaction gaps &gt; 35 days as 'at-risk'.</a:t>
+            </a:r>
+          </a:p>
+          <a:p>
+            <a:pPr>
+              <a:spcAft>
+                <a:spcPts val="800"/>
+              </a:spcAft>
+              <a:defRPr sz="1600">
+                <a:solidFill>
+                  <a:srgbClr val="0F172A"/>
+                </a:solidFill>
+                <a:latin typeface="Arial"/>
+              </a:defRPr>
+            </a:pPr>
+            <a:r>
+              <a:t>Risk Recommender Engine (recommender.py)</a:t>
+            </a:r>
+          </a:p>
+          <a:p>
+            <a:pPr lvl="1">
+              <a:defRPr sz="1600">
+                <a:solidFill>
+                  <a:srgbClr val="0F172A"/>
+                </a:solidFill>
+                <a:latin typeface="Arial"/>
+              </a:defRPr>
+            </a:pPr>
+            <a:r>
+              <a:t>Programmatic lookup matching risk appetites to top Sharpe ratio funds.</a:t>
+            </a:r>
+          </a:p>
+        </p:txBody>
+      </p:sp>
+    </p:spTree>
+  </p:cSld>
+  <p:clrMapOvr>
+    <a:masterClrMapping/>
+  </p:clrMapOvr>
+</p:sld>
+</file>
+
+<file path=ppt/slides/slide15.xml><?xml version="1.0" encoding="utf-8"?>
+<p:sld xmlns:a="http://schemas.openxmlformats.org/drawingml/2006/main" xmlns:p="http://schemas.openxmlformats.org/presentationml/2006/main" xmlns:r="http://schemas.openxmlformats.org/officeDocument/2006/relationships">
+  <p:cSld>
+    <p:spTree>
+      <p:nvGrpSpPr>
+        <p:cNvPr id="1" name=""/>
+        <p:cNvGrpSpPr/>
+        <p:nvPr/>
+      </p:nvGrpSpPr>
+      <p:grpSpPr/>
+      <p:sp>
+        <p:nvSpPr>
+          <p:cNvPr id="2" name="TextBox 1"/>
+          <p:cNvSpPr txBox="1"/>
+          <p:nvPr/>
+        </p:nvSpPr>
+        <p:spPr>
+          <a:xfrm>
+            <a:off x="457200" y="365760"/>
+            <a:ext cx="8229600" cy="731520"/>
+          </a:xfrm>
+          <a:prstGeom prst="rect">
+            <a:avLst/>
+          </a:prstGeom>
+          <a:noFill/>
+        </p:spPr>
+        <p:txBody>
+          <a:bodyPr wrap="square">
+            <a:spAutoFit/>
+          </a:bodyPr>
+          <a:lstStyle/>
+          <a:p>
+            <a:pPr>
+              <a:defRPr sz="3600" b="1">
+                <a:solidFill>
+                  <a:srgbClr val="1E3A8A"/>
+                </a:solidFill>
+                <a:latin typeface="Arial"/>
+              </a:defRPr>
+            </a:pPr>
+            <a:r>
               <a:t>Strategic Business Recommendations</a:t>
             </a:r>
           </a:p>
@@ -4985,7 +5603,7 @@
               </a:defRPr>
             </a:pPr>
             <a:r>
-              <a:t>EDA: NAV Trends &amp; Market Growth</a:t>
+              <a:t>EDA: NAV Trends &amp; AUM Growth</a:t>
             </a:r>
           </a:p>
         </p:txBody>
@@ -5024,7 +5642,7 @@
               </a:defRPr>
             </a:pPr>
             <a:r>
-              <a:t>NAV Historical Movement:</a:t>
+              <a:t>Historical NAV Trends:</a:t>
             </a:r>
           </a:p>
           <a:p>
@@ -5037,7 +5655,20 @@
               </a:defRPr>
             </a:pPr>
             <a:r>
-              <a:t>Solid post-2023 rally seen across Large Cap schemes.</a:t>
+              <a:t>Visualizes daily NAV for all 40 schemes (2022-2026).</a:t>
+            </a:r>
+          </a:p>
+          <a:p>
+            <a:pPr lvl="1">
+              <a:defRPr sz="1600">
+                <a:solidFill>
+                  <a:srgbClr val="0F172A"/>
+                </a:solidFill>
+                <a:latin typeface="Arial"/>
+              </a:defRPr>
+            </a:pPr>
+            <a:r>
+              <a:t>Highlights the 2023 Bull Run and 2024 Corrections.</a:t>
             </a:r>
           </a:p>
           <a:p>
@@ -5053,7 +5684,7 @@
               </a:defRPr>
             </a:pPr>
             <a:r>
-              <a:t>AMC AUM comparison:</a:t>
+              <a:t>Assets Under Management Progression:</a:t>
             </a:r>
           </a:p>
           <a:p>
@@ -5066,23 +5697,7 @@
               </a:defRPr>
             </a:pPr>
             <a:r>
-              <a:t>SBI MF leads, followed by ICICI Pru and HDFC MF.</a:t>
-            </a:r>
-          </a:p>
-          <a:p>
-            <a:pPr>
-              <a:spcAft>
-                <a:spcPts val="800"/>
-              </a:spcAft>
-              <a:defRPr sz="1600">
-                <a:solidFill>
-                  <a:srgbClr val="0F172A"/>
-                </a:solidFill>
-                <a:latin typeface="Arial"/>
-              </a:defRPr>
-            </a:pPr>
-            <a:r>
-              <a:t>Category Heatmap:</a:t>
+              <a:t>Tracks average yearly AUM by fund house.</a:t>
             </a:r>
           </a:p>
           <a:p>
@@ -5095,7 +5710,7 @@
               </a:defRPr>
             </a:pPr>
             <a:r>
-              <a:t>Net inflows heavily concentrate in Liquid cash funds.</a:t>
+              <a:t>Highlights SBI MF's dominance, touching ₹12.5L Cr in 2025.</a:t>
             </a:r>
           </a:p>
         </p:txBody>
@@ -5116,8 +5731,8 @@
         </p:blipFill>
         <p:spPr>
           <a:xfrm>
-            <a:off x="4572000" y="1188720"/>
-            <a:ext cx="4114800" cy="2377440"/>
+            <a:off x="4754880" y="1188720"/>
+            <a:ext cx="3931920" cy="2377440"/>
           </a:xfrm>
           <a:prstGeom prst="rect">
             <a:avLst/>
@@ -5140,8 +5755,8 @@
         </p:blipFill>
         <p:spPr>
           <a:xfrm>
-            <a:off x="4572000" y="3657600"/>
-            <a:ext cx="4114800" cy="2377440"/>
+            <a:off x="4754880" y="3840480"/>
+            <a:ext cx="3931920" cy="2377440"/>
           </a:xfrm>
           <a:prstGeom prst="rect">
             <a:avLst/>
@@ -5197,7 +5812,7 @@
               </a:defRPr>
             </a:pPr>
             <a:r>
-              <a:t>EDA: Investor Segmentation</a:t>
+              <a:t>EDA: Inflows &amp; Category Heatmap</a:t>
             </a:r>
           </a:p>
         </p:txBody>
@@ -5236,7 +5851,7 @@
               </a:defRPr>
             </a:pPr>
             <a:r>
-              <a:t>Age Group Splits:</a:t>
+              <a:t>Monthly Systematic Investment Plans (SIP):</a:t>
             </a:r>
           </a:p>
           <a:p>
@@ -5249,7 +5864,20 @@
               </a:defRPr>
             </a:pPr>
             <a:r>
-              <a:t>26-35 age bracket dominates active count (36%).</a:t>
+              <a:t>Robust growth in retail industry SIP inflows.</a:t>
+            </a:r>
+          </a:p>
+          <a:p>
+            <a:pPr lvl="1">
+              <a:defRPr sz="1600">
+                <a:solidFill>
+                  <a:srgbClr val="0F172A"/>
+                </a:solidFill>
+                <a:latin typeface="Arial"/>
+              </a:defRPr>
+            </a:pPr>
+            <a:r>
+              <a:t>Peaked at an all-time high of ₹31,002 Cr in Dec 2025.</a:t>
             </a:r>
           </a:p>
           <a:p>
@@ -5265,7 +5893,7 @@
               </a:defRPr>
             </a:pPr>
             <a:r>
-              <a:t>Geographic analysis:</a:t>
+              <a:t>Category Net Inflows Heatmap:</a:t>
             </a:r>
           </a:p>
           <a:p>
@@ -5278,23 +5906,7 @@
               </a:defRPr>
             </a:pPr>
             <a:r>
-              <a:t>Punjab, Tamil Nadu and Rajasthan have top SIP volumes.</a:t>
-            </a:r>
-          </a:p>
-          <a:p>
-            <a:pPr>
-              <a:spcAft>
-                <a:spcPts val="800"/>
-              </a:spcAft>
-              <a:defRPr sz="1600">
-                <a:solidFill>
-                  <a:srgbClr val="0F172A"/>
-                </a:solidFill>
-                <a:latin typeface="Arial"/>
-              </a:defRPr>
-            </a:pPr>
-            <a:r>
-              <a:t>Folio Expansion:</a:t>
+              <a:t>Reveals net inflow distribution across 12 fund categories.</a:t>
             </a:r>
           </a:p>
           <a:p>
@@ -5307,14 +5919,14 @@
               </a:defRPr>
             </a:pPr>
             <a:r>
-              <a:t>Total folios doubled from 13.26 Cr (2022) to 26.12 Cr (2025).</a:t>
+              <a:t>Highlights Liquid funds as dominant short-term cash reserves.</a:t>
             </a:r>
           </a:p>
         </p:txBody>
       </p:sp>
       <p:pic>
         <p:nvPicPr>
-          <p:cNvPr id="4" name="Picture 3" descr="investor_demographics.png"/>
+          <p:cNvPr id="4" name="Picture 3" descr="sip_inflows.png"/>
           <p:cNvPicPr>
             <a:picLocks noChangeAspect="1"/>
           </p:cNvPicPr>
@@ -5328,8 +5940,8 @@
         </p:blipFill>
         <p:spPr>
           <a:xfrm>
-            <a:off x="4572000" y="1188720"/>
-            <a:ext cx="4114800" cy="2377440"/>
+            <a:off x="4754880" y="1188720"/>
+            <a:ext cx="3931920" cy="2377440"/>
           </a:xfrm>
           <a:prstGeom prst="rect">
             <a:avLst/>
@@ -5338,7 +5950,7 @@
       </p:pic>
       <p:pic>
         <p:nvPicPr>
-          <p:cNvPr id="5" name="Picture 4" descr="geo_distribution.png"/>
+          <p:cNvPr id="5" name="Picture 4" descr="category_inflow_heatmap.png"/>
           <p:cNvPicPr>
             <a:picLocks noChangeAspect="1"/>
           </p:cNvPicPr>
@@ -5352,8 +5964,8 @@
         </p:blipFill>
         <p:spPr>
           <a:xfrm>
-            <a:off x="4572000" y="3657600"/>
-            <a:ext cx="4114800" cy="2377440"/>
+            <a:off x="4754880" y="3840480"/>
+            <a:ext cx="3931920" cy="2377440"/>
           </a:xfrm>
           <a:prstGeom prst="rect">
             <a:avLst/>

</xml_diff>